<commit_message>
Update Sampling presentation (03_Sampling.pptx)
Replace 2026_SMDM/03_Sampling.pptx with an updated PowerPoint: content and slide layout adjustments for the 2026_SMDM Sampling module. This is a binary file change (no source code modified).
</commit_message>
<xml_diff>
--- a/2026_SMDM/03_Sampling.pptx
+++ b/2026_SMDM/03_Sampling.pptx
@@ -5,7 +5,7 @@
     <p:sldMasterId id="2147483648" r:id="rId4"/>
   </p:sldMasterIdLst>
   <p:notesMasterIdLst>
-    <p:notesMasterId r:id="rId33"/>
+    <p:notesMasterId r:id="rId34"/>
   </p:notesMasterIdLst>
   <p:sldIdLst>
     <p:sldId id="1100" r:id="rId5"/>
@@ -34,8 +34,9 @@
     <p:sldId id="1107" r:id="rId28"/>
     <p:sldId id="1109" r:id="rId29"/>
     <p:sldId id="1110" r:id="rId30"/>
-    <p:sldId id="1079" r:id="rId31"/>
-    <p:sldId id="1101" r:id="rId32"/>
+    <p:sldId id="1111" r:id="rId31"/>
+    <p:sldId id="1079" r:id="rId32"/>
+    <p:sldId id="1101" r:id="rId33"/>
   </p:sldIdLst>
   <p:sldSz cx="12192000" cy="6858000"/>
   <p:notesSz cx="6858000" cy="9144000"/>
@@ -235,7 +236,7 @@
           <a:p>
             <a:fld id="{E033252C-ECEF-0044-BF19-FBFB46CE84A2}" type="datetimeFigureOut">
               <a:rPr lang="en-US" smtClean="0"/>
-              <a:t>6/27/26</a:t>
+              <a:t>6/28/26</a:t>
             </a:fld>
             <a:endParaRPr lang="en-US"/>
           </a:p>
@@ -733,7 +734,7 @@
           <a:p>
             <a:fld id="{6A8FB48A-BFC4-2846-8228-6201ABA4D0C5}" type="datetimeFigureOut">
               <a:rPr lang="en-US" smtClean="0"/>
-              <a:t>6/27/26</a:t>
+              <a:t>6/28/26</a:t>
             </a:fld>
             <a:endParaRPr lang="en-US"/>
           </a:p>
@@ -931,7 +932,7 @@
           <a:p>
             <a:fld id="{6A8FB48A-BFC4-2846-8228-6201ABA4D0C5}" type="datetimeFigureOut">
               <a:rPr lang="en-US" smtClean="0"/>
-              <a:t>6/27/26</a:t>
+              <a:t>6/28/26</a:t>
             </a:fld>
             <a:endParaRPr lang="en-US"/>
           </a:p>
@@ -1139,7 +1140,7 @@
           <a:p>
             <a:fld id="{6A8FB48A-BFC4-2846-8228-6201ABA4D0C5}" type="datetimeFigureOut">
               <a:rPr lang="en-US" smtClean="0"/>
-              <a:t>6/27/26</a:t>
+              <a:t>6/28/26</a:t>
             </a:fld>
             <a:endParaRPr lang="en-US"/>
           </a:p>
@@ -1337,7 +1338,7 @@
           <a:p>
             <a:fld id="{6A8FB48A-BFC4-2846-8228-6201ABA4D0C5}" type="datetimeFigureOut">
               <a:rPr lang="en-US" smtClean="0"/>
-              <a:t>6/27/26</a:t>
+              <a:t>6/28/26</a:t>
             </a:fld>
             <a:endParaRPr lang="en-US"/>
           </a:p>
@@ -1612,7 +1613,7 @@
           <a:p>
             <a:fld id="{6A8FB48A-BFC4-2846-8228-6201ABA4D0C5}" type="datetimeFigureOut">
               <a:rPr lang="en-US" smtClean="0"/>
-              <a:t>6/27/26</a:t>
+              <a:t>6/28/26</a:t>
             </a:fld>
             <a:endParaRPr lang="en-US"/>
           </a:p>
@@ -1877,7 +1878,7 @@
           <a:p>
             <a:fld id="{6A8FB48A-BFC4-2846-8228-6201ABA4D0C5}" type="datetimeFigureOut">
               <a:rPr lang="en-US" smtClean="0"/>
-              <a:t>6/27/26</a:t>
+              <a:t>6/28/26</a:t>
             </a:fld>
             <a:endParaRPr lang="en-US"/>
           </a:p>
@@ -2289,7 +2290,7 @@
           <a:p>
             <a:fld id="{6A8FB48A-BFC4-2846-8228-6201ABA4D0C5}" type="datetimeFigureOut">
               <a:rPr lang="en-US" smtClean="0"/>
-              <a:t>6/27/26</a:t>
+              <a:t>6/28/26</a:t>
             </a:fld>
             <a:endParaRPr lang="en-US"/>
           </a:p>
@@ -2430,7 +2431,7 @@
           <a:p>
             <a:fld id="{6A8FB48A-BFC4-2846-8228-6201ABA4D0C5}" type="datetimeFigureOut">
               <a:rPr lang="en-US" smtClean="0"/>
-              <a:t>6/27/26</a:t>
+              <a:t>6/28/26</a:t>
             </a:fld>
             <a:endParaRPr lang="en-US"/>
           </a:p>
@@ -2543,7 +2544,7 @@
           <a:p>
             <a:fld id="{6A8FB48A-BFC4-2846-8228-6201ABA4D0C5}" type="datetimeFigureOut">
               <a:rPr lang="en-US" smtClean="0"/>
-              <a:t>6/27/26</a:t>
+              <a:t>6/28/26</a:t>
             </a:fld>
             <a:endParaRPr lang="en-US"/>
           </a:p>
@@ -2854,7 +2855,7 @@
           <a:p>
             <a:fld id="{6A8FB48A-BFC4-2846-8228-6201ABA4D0C5}" type="datetimeFigureOut">
               <a:rPr lang="en-US" smtClean="0"/>
-              <a:t>6/27/26</a:t>
+              <a:t>6/28/26</a:t>
             </a:fld>
             <a:endParaRPr lang="en-US"/>
           </a:p>
@@ -3142,7 +3143,7 @@
           <a:p>
             <a:fld id="{6A8FB48A-BFC4-2846-8228-6201ABA4D0C5}" type="datetimeFigureOut">
               <a:rPr lang="en-US" smtClean="0"/>
-              <a:t>6/27/26</a:t>
+              <a:t>6/28/26</a:t>
             </a:fld>
             <a:endParaRPr lang="en-US"/>
           </a:p>
@@ -3383,7 +3384,7 @@
           <a:p>
             <a:fld id="{6A8FB48A-BFC4-2846-8228-6201ABA4D0C5}" type="datetimeFigureOut">
               <a:rPr lang="en-US" smtClean="0"/>
-              <a:t>6/27/26</a:t>
+              <a:t>6/28/26</a:t>
             </a:fld>
             <a:endParaRPr lang="en-US"/>
           </a:p>
@@ -15462,6 +15463,197 @@
   <p:cSld>
     <p:spTree>
       <p:nvGrpSpPr>
+        <p:cNvPr id="1" name="">
+          <a:extLst>
+            <a:ext uri="{FF2B5EF4-FFF2-40B4-BE49-F238E27FC236}">
+              <a16:creationId xmlns:a16="http://schemas.microsoft.com/office/drawing/2014/main" id="{31D4FCFA-BF43-2E61-DD9A-9DEA9DE9FD40}"/>
+            </a:ext>
+          </a:extLst>
+        </p:cNvPr>
+        <p:cNvGrpSpPr/>
+        <p:nvPr/>
+      </p:nvGrpSpPr>
+      <p:grpSpPr>
+        <a:xfrm>
+          <a:off x="0" y="0"/>
+          <a:ext cx="0" cy="0"/>
+          <a:chOff x="0" y="0"/>
+          <a:chExt cx="0" cy="0"/>
+        </a:xfrm>
+      </p:grpSpPr>
+      <p:pic>
+        <p:nvPicPr>
+          <p:cNvPr id="10" name="Picture 9">
+            <a:extLst>
+              <a:ext uri="{FF2B5EF4-FFF2-40B4-BE49-F238E27FC236}">
+                <a16:creationId xmlns:a16="http://schemas.microsoft.com/office/drawing/2014/main" id="{E99AC403-2E2C-4CAF-1B4F-F2CA36DFCAB9}"/>
+              </a:ext>
+            </a:extLst>
+          </p:cNvPr>
+          <p:cNvPicPr>
+            <a:picLocks noChangeAspect="1"/>
+          </p:cNvPicPr>
+          <p:nvPr/>
+        </p:nvPicPr>
+        <p:blipFill>
+          <a:blip r:embed="rId2"/>
+          <a:stretch>
+            <a:fillRect/>
+          </a:stretch>
+        </p:blipFill>
+        <p:spPr>
+          <a:xfrm>
+            <a:off x="4751295" y="4281229"/>
+            <a:ext cx="7440706" cy="2576771"/>
+          </a:xfrm>
+          <a:prstGeom prst="rect">
+            <a:avLst/>
+          </a:prstGeom>
+        </p:spPr>
+      </p:pic>
+      <p:sp>
+        <p:nvSpPr>
+          <p:cNvPr id="14" name="Title 13">
+            <a:extLst>
+              <a:ext uri="{FF2B5EF4-FFF2-40B4-BE49-F238E27FC236}">
+                <a16:creationId xmlns:a16="http://schemas.microsoft.com/office/drawing/2014/main" id="{21EB19F1-271F-6355-88E5-9D7FD1270696}"/>
+              </a:ext>
+            </a:extLst>
+          </p:cNvPr>
+          <p:cNvSpPr>
+            <a:spLocks noGrp="1"/>
+          </p:cNvSpPr>
+          <p:nvPr>
+            <p:ph type="title"/>
+          </p:nvPr>
+        </p:nvSpPr>
+        <p:spPr>
+          <a:xfrm>
+            <a:off x="838200" y="552954"/>
+            <a:ext cx="10515600" cy="765544"/>
+          </a:xfrm>
+        </p:spPr>
+        <p:txBody>
+          <a:bodyPr/>
+          <a:lstStyle/>
+          <a:p>
+            <a:r>
+              <a:rPr lang="en-US" dirty="0"/>
+              <a:t>More in these works…</a:t>
+            </a:r>
+          </a:p>
+        </p:txBody>
+      </p:sp>
+      <p:pic>
+        <p:nvPicPr>
+          <p:cNvPr id="5" name="Picture 4">
+            <a:extLst>
+              <a:ext uri="{FF2B5EF4-FFF2-40B4-BE49-F238E27FC236}">
+                <a16:creationId xmlns:a16="http://schemas.microsoft.com/office/drawing/2014/main" id="{AFB5E61A-1A18-441D-5037-15C543B26B5E}"/>
+              </a:ext>
+            </a:extLst>
+          </p:cNvPr>
+          <p:cNvPicPr>
+            <a:picLocks noChangeAspect="1"/>
+          </p:cNvPicPr>
+          <p:nvPr/>
+        </p:nvPicPr>
+        <p:blipFill>
+          <a:blip r:embed="rId3"/>
+          <a:stretch>
+            <a:fillRect/>
+          </a:stretch>
+        </p:blipFill>
+        <p:spPr>
+          <a:xfrm>
+            <a:off x="526351" y="1295343"/>
+            <a:ext cx="7033460" cy="3086884"/>
+          </a:xfrm>
+          <a:prstGeom prst="rect">
+            <a:avLst/>
+          </a:prstGeom>
+        </p:spPr>
+      </p:pic>
+      <p:sp>
+        <p:nvSpPr>
+          <p:cNvPr id="11" name="TextBox 10">
+            <a:extLst>
+              <a:ext uri="{FF2B5EF4-FFF2-40B4-BE49-F238E27FC236}">
+                <a16:creationId xmlns:a16="http://schemas.microsoft.com/office/drawing/2014/main" id="{3EDA273B-E45E-FC4C-506D-393BACE26FD8}"/>
+              </a:ext>
+            </a:extLst>
+          </p:cNvPr>
+          <p:cNvSpPr txBox="1"/>
+          <p:nvPr/>
+        </p:nvSpPr>
+        <p:spPr>
+          <a:xfrm>
+            <a:off x="2580096" y="4108260"/>
+            <a:ext cx="5824152" cy="261610"/>
+          </a:xfrm>
+          <a:prstGeom prst="rect">
+            <a:avLst/>
+          </a:prstGeom>
+          <a:noFill/>
+        </p:spPr>
+        <p:txBody>
+          <a:bodyPr wrap="square">
+            <a:spAutoFit/>
+          </a:bodyPr>
+          <a:lstStyle/>
+          <a:p>
+            <a:r>
+              <a:rPr lang="en-US" sz="1100" b="0" i="0" u="none" strike="noStrike" dirty="0">
+                <a:solidFill>
+                  <a:srgbClr val="222222"/>
+                </a:solidFill>
+                <a:effectLst/>
+                <a:latin typeface="Merriweather Sans" pitchFamily="2" charset="77"/>
+              </a:rPr>
+              <a:t>https://</a:t>
+            </a:r>
+            <a:r>
+              <a:rPr lang="en-US" sz="1100" b="0" i="0" u="none" strike="noStrike" dirty="0" err="1">
+                <a:solidFill>
+                  <a:srgbClr val="222222"/>
+                </a:solidFill>
+                <a:effectLst/>
+                <a:latin typeface="Merriweather Sans" pitchFamily="2" charset="77"/>
+              </a:rPr>
+              <a:t>doi.org</a:t>
+            </a:r>
+            <a:r>
+              <a:rPr lang="en-US" sz="1100" b="0" i="0" u="none" strike="noStrike" dirty="0">
+                <a:solidFill>
+                  <a:srgbClr val="222222"/>
+                </a:solidFill>
+                <a:effectLst/>
+                <a:latin typeface="Merriweather Sans" pitchFamily="2" charset="77"/>
+              </a:rPr>
+              <a:t>/10.1007/s40273-025-01571-3</a:t>
+            </a:r>
+            <a:endParaRPr lang="en-US" sz="1100" dirty="0"/>
+          </a:p>
+        </p:txBody>
+      </p:sp>
+    </p:spTree>
+    <p:extLst>
+      <p:ext uri="{BB962C8B-B14F-4D97-AF65-F5344CB8AC3E}">
+        <p14:creationId xmlns:p14="http://schemas.microsoft.com/office/powerpoint/2010/main" val="1847581528"/>
+      </p:ext>
+    </p:extLst>
+  </p:cSld>
+  <p:clrMapOvr>
+    <a:masterClrMapping/>
+  </p:clrMapOvr>
+</p:sld>
+</file>
+
+<file path=ppt/slides/slide28.xml><?xml version="1.0" encoding="utf-8"?>
+<p:sld xmlns:a="http://schemas.openxmlformats.org/drawingml/2006/main" xmlns:r="http://schemas.openxmlformats.org/officeDocument/2006/relationships" xmlns:p="http://schemas.openxmlformats.org/presentationml/2006/main">
+  <p:cSld>
+    <p:spTree>
+      <p:nvGrpSpPr>
         <p:cNvPr id="1" name=""/>
         <p:cNvGrpSpPr/>
         <p:nvPr/>
@@ -15515,7 +15707,7 @@
 </p:sld>
 </file>
 
-<file path=ppt/slides/slide28.xml><?xml version="1.0" encoding="utf-8"?>
+<file path=ppt/slides/slide29.xml><?xml version="1.0" encoding="utf-8"?>
 <p:sld xmlns:a="http://schemas.openxmlformats.org/drawingml/2006/main" xmlns:r="http://schemas.openxmlformats.org/officeDocument/2006/relationships" xmlns:p="http://schemas.openxmlformats.org/presentationml/2006/main">
   <p:cSld>
     <p:spTree>
@@ -20918,17 +21110,6 @@
 </file>
 
 <file path=customXml/item1.xml><?xml version="1.0" encoding="utf-8"?>
-<p:properties xmlns:p="http://schemas.microsoft.com/office/2006/metadata/properties" xmlns:xsi="http://www.w3.org/2001/XMLSchema-instance" xmlns:pc="http://schemas.microsoft.com/office/infopath/2007/PartnerControls">
-  <documentManagement>
-    <TaxCatchAll xmlns="b6c9d19c-b34a-4cf4-8ebf-64c63fc48083" xsi:nil="true"/>
-    <lcf76f155ced4ddcb4097134ff3c332f xmlns="33f92c16-e346-46b5-ac57-2b519ac4cf68">
-      <Terms xmlns="http://schemas.microsoft.com/office/infopath/2007/PartnerControls"/>
-    </lcf76f155ced4ddcb4097134ff3c332f>
-  </documentManagement>
-</p:properties>
-</file>
-
-<file path=customXml/item2.xml><?xml version="1.0" encoding="utf-8"?>
 <ct:contentTypeSchema xmlns:ct="http://schemas.microsoft.com/office/2006/metadata/contentType" xmlns:ma="http://schemas.microsoft.com/office/2006/metadata/properties/metaAttributes" ct:_="" ma:_="" ma:contentTypeName="Document" ma:contentTypeID="0x0101007069032936BB004A979B3FCE77DE1EB1" ma:contentTypeVersion="16" ma:contentTypeDescription="Create a new document." ma:contentTypeScope="" ma:versionID="59b39aa881a230c9f06045ed60478b88">
   <xsd:schema xmlns:xsd="http://www.w3.org/2001/XMLSchema" xmlns:xs="http://www.w3.org/2001/XMLSchema" xmlns:p="http://schemas.microsoft.com/office/2006/metadata/properties" xmlns:ns2="33f92c16-e346-46b5-ac57-2b519ac4cf68" xmlns:ns3="0efde304-9646-43d8-8eee-5b1a55ab17f1" xmlns:ns4="b6c9d19c-b34a-4cf4-8ebf-64c63fc48083" targetNamespace="http://schemas.microsoft.com/office/2006/metadata/properties" ma:root="true" ma:fieldsID="c596c03b60b8e16cee14ab235af6374a" ns2:_="" ns3:_="" ns4:_="">
     <xsd:import namespace="33f92c16-e346-46b5-ac57-2b519ac4cf68"/>
@@ -21168,6 +21349,17 @@
 </ct:contentTypeSchema>
 </file>
 
+<file path=customXml/item2.xml><?xml version="1.0" encoding="utf-8"?>
+<p:properties xmlns:p="http://schemas.microsoft.com/office/2006/metadata/properties" xmlns:xsi="http://www.w3.org/2001/XMLSchema-instance" xmlns:pc="http://schemas.microsoft.com/office/infopath/2007/PartnerControls">
+  <documentManagement>
+    <TaxCatchAll xmlns="b6c9d19c-b34a-4cf4-8ebf-64c63fc48083" xsi:nil="true"/>
+    <lcf76f155ced4ddcb4097134ff3c332f xmlns="33f92c16-e346-46b5-ac57-2b519ac4cf68">
+      <Terms xmlns="http://schemas.microsoft.com/office/infopath/2007/PartnerControls"/>
+    </lcf76f155ced4ddcb4097134ff3c332f>
+  </documentManagement>
+</p:properties>
+</file>
+
 <file path=customXml/item3.xml><?xml version="1.0" encoding="utf-8"?>
 <?mso-contentType ?>
 <FormTemplates xmlns="http://schemas.microsoft.com/sharepoint/v3/contenttype/forms">
@@ -21178,24 +21370,6 @@
 </file>
 
 <file path=customXml/itemProps1.xml><?xml version="1.0" encoding="utf-8"?>
-<ds:datastoreItem xmlns:ds="http://schemas.openxmlformats.org/officeDocument/2006/customXml" ds:itemID="{E709C047-1DE0-4980-A90A-4D5EFC165D2C}">
-  <ds:schemaRefs>
-    <ds:schemaRef ds:uri="0efde304-9646-43d8-8eee-5b1a55ab17f1"/>
-    <ds:schemaRef ds:uri="33f92c16-e346-46b5-ac57-2b519ac4cf68"/>
-    <ds:schemaRef ds:uri="b6c9d19c-b34a-4cf4-8ebf-64c63fc48083"/>
-    <ds:schemaRef ds:uri="http://purl.org/dc/dcmitype/"/>
-    <ds:schemaRef ds:uri="http://purl.org/dc/elements/1.1/"/>
-    <ds:schemaRef ds:uri="http://purl.org/dc/terms/"/>
-    <ds:schemaRef ds:uri="http://schemas.microsoft.com/office/2006/documentManagement/types"/>
-    <ds:schemaRef ds:uri="http://schemas.microsoft.com/office/2006/metadata/properties"/>
-    <ds:schemaRef ds:uri="http://schemas.microsoft.com/office/infopath/2007/PartnerControls"/>
-    <ds:schemaRef ds:uri="http://schemas.openxmlformats.org/package/2006/metadata/core-properties"/>
-    <ds:schemaRef ds:uri="http://www.w3.org/XML/1998/namespace"/>
-  </ds:schemaRefs>
-</ds:datastoreItem>
-</file>
-
-<file path=customXml/itemProps2.xml><?xml version="1.0" encoding="utf-8"?>
 <ds:datastoreItem xmlns:ds="http://schemas.openxmlformats.org/officeDocument/2006/customXml" ds:itemID="{2D7DA705-6300-4113-B183-485198D9C84E}">
   <ds:schemaRefs>
     <ds:schemaRef ds:uri="0efde304-9646-43d8-8eee-5b1a55ab17f1"/>
@@ -21215,6 +21389,24 @@
 </ds:datastoreItem>
 </file>
 
+<file path=customXml/itemProps2.xml><?xml version="1.0" encoding="utf-8"?>
+<ds:datastoreItem xmlns:ds="http://schemas.openxmlformats.org/officeDocument/2006/customXml" ds:itemID="{E709C047-1DE0-4980-A90A-4D5EFC165D2C}">
+  <ds:schemaRefs>
+    <ds:schemaRef ds:uri="0efde304-9646-43d8-8eee-5b1a55ab17f1"/>
+    <ds:schemaRef ds:uri="33f92c16-e346-46b5-ac57-2b519ac4cf68"/>
+    <ds:schemaRef ds:uri="b6c9d19c-b34a-4cf4-8ebf-64c63fc48083"/>
+    <ds:schemaRef ds:uri="http://purl.org/dc/dcmitype/"/>
+    <ds:schemaRef ds:uri="http://purl.org/dc/elements/1.1/"/>
+    <ds:schemaRef ds:uri="http://purl.org/dc/terms/"/>
+    <ds:schemaRef ds:uri="http://schemas.microsoft.com/office/2006/documentManagement/types"/>
+    <ds:schemaRef ds:uri="http://schemas.microsoft.com/office/2006/metadata/properties"/>
+    <ds:schemaRef ds:uri="http://schemas.microsoft.com/office/infopath/2007/PartnerControls"/>
+    <ds:schemaRef ds:uri="http://schemas.openxmlformats.org/package/2006/metadata/core-properties"/>
+    <ds:schemaRef ds:uri="http://www.w3.org/XML/1998/namespace"/>
+  </ds:schemaRefs>
+</ds:datastoreItem>
+</file>
+
 <file path=customXml/itemProps3.xml><?xml version="1.0" encoding="utf-8"?>
 <ds:datastoreItem xmlns:ds="http://schemas.openxmlformats.org/officeDocument/2006/customXml" ds:itemID="{EF0BFC65-ABD5-40EA-BAE0-821B9D6524E8}">
   <ds:schemaRefs>

</xml_diff>